<commit_message>
chore: update compliance deck
Co-Authored-By: Claude Fable 5 <noreply@anthropic.com>
</commit_message>
<xml_diff>
--- a/KubeGuard_Compliance.pptx
+++ b/KubeGuard_Compliance.pptx
@@ -15,6 +15,8 @@
     <p:sldId id="263" r:id="rId9"/>
     <p:sldId id="264" r:id="rId10"/>
     <p:sldId id="265" r:id="rId11"/>
+    <p:sldId id="267" r:id="rId18"/>
+    <p:sldId id="268" r:id="rId19"/>
     <p:sldId id="266" r:id="rId12"/>
   </p:sldIdLst>
   <p:notesMasterIdLst>
@@ -1787,7 +1789,7 @@
       </p:sp>
       <p:pic>
         <p:nvPicPr>
-          <p:cNvPr id="3" name="Image 0" descr="preencoded.png">    </p:cNvPr>
+          <p:cNvPr id="3" name="Image 0" descr="preencoded.png"/>
           <p:cNvPicPr>
             <a:picLocks noChangeAspect="1"/>
           </p:cNvPicPr>
@@ -2487,7 +2489,7 @@
       </p:sp>
       <p:pic>
         <p:nvPicPr>
-          <p:cNvPr id="6" name="Image 0" descr="preencoded.png">    </p:cNvPr>
+          <p:cNvPr id="6" name="Image 0" descr="preencoded.png"/>
           <p:cNvPicPr>
             <a:picLocks noChangeAspect="1"/>
           </p:cNvPicPr>
@@ -2584,7 +2586,7 @@
                 <a:ea typeface="Calibri" pitchFamily="34" charset="-122"/>
                 <a:cs typeface="Calibri" pitchFamily="34" charset="-120"/>
               </a:rPr>
-              <a:t>Console, JSON, SARIF 2.1.0 and a self-contained HTML dashboard — plus file/SQLite history for drift over time.</a:t>
+              <a:t>Console, JSON, SARIF 2.1.0, a self-contained HTML dashboard, and per-framework auditor evidence packs — plus file/SQLite history for drift over time.</a:t>
             </a:r>
             <a:endParaRPr lang="en-US" sz="1200" dirty="0"/>
           </a:p>
@@ -2637,7 +2639,7 @@
       </p:sp>
       <p:pic>
         <p:nvPicPr>
-          <p:cNvPr id="11" name="Image 1" descr="preencoded.png">    </p:cNvPr>
+          <p:cNvPr id="11" name="Image 1" descr="preencoded.png"/>
           <p:cNvPicPr>
             <a:picLocks noChangeAspect="1"/>
           </p:cNvPicPr>
@@ -2787,7 +2789,7 @@
       </p:sp>
       <p:pic>
         <p:nvPicPr>
-          <p:cNvPr id="16" name="Image 2" descr="preencoded.png">    </p:cNvPr>
+          <p:cNvPr id="16" name="Image 2" descr="preencoded.png"/>
           <p:cNvPicPr>
             <a:picLocks noChangeAspect="1"/>
           </p:cNvPicPr>
@@ -2937,7 +2939,7 @@
       </p:sp>
       <p:pic>
         <p:nvPicPr>
-          <p:cNvPr id="21" name="Image 3" descr="preencoded.png">    </p:cNvPr>
+          <p:cNvPr id="21" name="Image 3" descr="preencoded.png"/>
           <p:cNvPicPr>
             <a:picLocks noChangeAspect="1"/>
           </p:cNvPicPr>
@@ -3094,7 +3096,7 @@
       </p:sp>
       <p:pic>
         <p:nvPicPr>
-          <p:cNvPr id="3" name="Image 0" descr="preencoded.png">    </p:cNvPr>
+          <p:cNvPr id="3" name="Image 0" descr="preencoded.png"/>
           <p:cNvPicPr>
             <a:picLocks noChangeAspect="1"/>
           </p:cNvPicPr>
@@ -3202,7 +3204,7 @@
                 <a:ea typeface="Calibri" pitchFamily="34" charset="-122"/>
                 <a:cs typeface="Calibri" pitchFamily="34" charset="-120"/>
               </a:rPr>
-              <a:t>   ·   </a:t>
+              <a:t xml:space="preserve">   ·   </a:t>
             </a:r>
             <a:pPr indent="0" marL="0">
               <a:buNone/>
@@ -3230,7 +3232,7 @@
                 <a:ea typeface="Calibri" pitchFamily="34" charset="-122"/>
                 <a:cs typeface="Calibri" pitchFamily="34" charset="-120"/>
               </a:rPr>
-              <a:t>   ·   </a:t>
+              <a:t xml:space="preserve">   ·   </a:t>
             </a:r>
             <a:pPr indent="0" marL="0">
               <a:buNone/>
@@ -3326,6 +3328,1725 @@
                 <a:cs typeface="Calibri" pitchFamily="34" charset="-120"/>
               </a:rPr>
               <a:t>Compliance pass-rates are reported as “breached / passed of assessed” with an indicative-mapping disclaimer — never a bare compliant verdict.</a:t>
+            </a:r>
+            <a:endParaRPr lang="en-US" sz="1150" dirty="0"/>
+          </a:p>
+        </p:txBody>
+      </p:sp>
+    </p:spTree>
+  </p:cSld>
+  <p:clrMapOvr>
+    <a:masterClrMapping/>
+  </p:clrMapOvr>
+</p:sld>
+</file>
+
+<file path=ppt/slides/slide12.xml><?xml version="1.0" encoding="utf-8"?>
+<p:sld xmlns:a="http://schemas.openxmlformats.org/drawingml/2006/main" xmlns:r="http://schemas.openxmlformats.org/officeDocument/2006/relationships" xmlns:p="http://schemas.openxmlformats.org/presentationml/2006/main">
+  <p:cSld name="Slide 7">
+    <p:bg>
+      <p:bgPr>
+        <a:solidFill>
+          <a:srgbClr val="FFFFFF"/>
+        </a:solidFill>
+      </p:bgPr>
+    </p:bg>
+    <p:spTree>
+      <p:nvGrpSpPr>
+        <p:cNvPr id="1" name=""/>
+        <p:cNvGrpSpPr/>
+        <p:nvPr/>
+      </p:nvGrpSpPr>
+      <p:grpSpPr>
+        <a:xfrm>
+          <a:off x="0" y="0"/>
+          <a:ext cx="0" cy="0"/>
+          <a:chOff x="0" y="0"/>
+          <a:chExt cx="0" cy="0"/>
+        </a:xfrm>
+      </p:grpSpPr>
+      <p:sp>
+        <p:nvSpPr>
+          <p:cNvPr id="4" name="Text 1"/>
+          <p:cNvSpPr/>
+          <p:nvPr/>
+        </p:nvSpPr>
+        <p:spPr>
+          <a:xfrm>
+            <a:off x="822960" y="566928"/>
+            <a:ext cx="10515600" cy="274320"/>
+          </a:xfrm>
+          <a:prstGeom prst="rect">
+            <a:avLst/>
+          </a:prstGeom>
+          <a:noFill/>
+          <a:ln/>
+        </p:spPr>
+        <p:txBody>
+          <a:bodyPr wrap="square" lIns="0" tIns="0" rIns="0" bIns="0" rtlCol="0" anchor="ctr"/>
+          <a:lstStyle/>
+          <a:p>
+            <a:pPr indent="0" marL="0">
+              <a:buNone/>
+            </a:pPr>
+            <a:r>
+              <a:rPr lang="en-US" sz="1200" b="1" spc="300" kern="0" dirty="0">
+                <a:solidFill>
+                  <a:srgbClr val="0D9488"/>
+                </a:solidFill>
+                <a:latin typeface="Calibri" pitchFamily="34" charset="0"/>
+                <a:ea typeface="Calibri" pitchFamily="34" charset="-122"/>
+                <a:cs typeface="Calibri" pitchFamily="34" charset="-120"/>
+              </a:rPr>
+              <a:t>WHERE IT FITS</a:t>
+            </a:r>
+            <a:endParaRPr lang="en-US" sz="1200" dirty="0"/>
+          </a:p>
+        </p:txBody>
+      </p:sp>
+      <p:sp>
+        <p:nvSpPr>
+          <p:cNvPr id="5" name="Text 2"/>
+          <p:cNvSpPr/>
+          <p:nvPr/>
+        </p:nvSpPr>
+        <p:spPr>
+          <a:xfrm>
+            <a:off x="822960" y="1143000"/>
+            <a:ext cx="10515600" cy="777240"/>
+          </a:xfrm>
+          <a:prstGeom prst="rect">
+            <a:avLst/>
+          </a:prstGeom>
+          <a:noFill/>
+          <a:ln/>
+        </p:spPr>
+        <p:txBody>
+          <a:bodyPr wrap="square" lIns="0" tIns="0" rIns="0" bIns="0" rtlCol="0" anchor="ctr"/>
+          <a:lstStyle/>
+          <a:p>
+            <a:pPr indent="0" marL="0">
+              <a:buNone/>
+            </a:pPr>
+            <a:r>
+              <a:rPr lang="en-US" sz="3000" b="1" dirty="0">
+                <a:solidFill>
+                  <a:srgbClr val="0E2A2B"/>
+                </a:solidFill>
+                <a:latin typeface="Georgia" pitchFamily="34" charset="0"/>
+                <a:ea typeface="Georgia" pitchFamily="34" charset="-122"/>
+                <a:cs typeface="Georgia" pitchFamily="34" charset="-120"/>
+              </a:rPr>
+              <a:t>How KubeGuard is different</a:t>
+            </a:r>
+            <a:endParaRPr lang="en-US" sz="3000" dirty="0"/>
+          </a:p>
+        </p:txBody>
+      </p:sp>
+      <p:sp>
+        <p:nvSpPr>
+          <p:cNvPr id="6" name="Text 3"/>
+          <p:cNvSpPr/>
+          <p:nvPr/>
+        </p:nvSpPr>
+        <p:spPr>
+          <a:xfrm>
+            <a:off x="822960" y="1828800"/>
+            <a:ext cx="10515600" cy="594360"/>
+          </a:xfrm>
+          <a:prstGeom prst="rect">
+            <a:avLst/>
+          </a:prstGeom>
+          <a:noFill/>
+          <a:ln/>
+        </p:spPr>
+        <p:txBody>
+          <a:bodyPr wrap="square" lIns="0" tIns="0" rIns="0" bIns="0" rtlCol="0" anchor="ctr"/>
+          <a:lstStyle/>
+          <a:p>
+            <a:pPr indent="0" marL="0">
+              <a:lnSpc>
+                <a:spcPct val="115000"/>
+              </a:lnSpc>
+              <a:buNone/>
+            </a:pPr>
+            <a:r>
+              <a:rPr lang="en-US" sz="1400" dirty="0">
+                <a:solidFill>
+                  <a:srgbClr val="475569"/>
+                </a:solidFill>
+                <a:latin typeface="Calibri" pitchFamily="34" charset="0"/>
+                <a:ea typeface="Calibri" pitchFamily="34" charset="-122"/>
+                <a:cs typeface="Calibri" pitchFamily="34" charset="-120"/>
+              </a:rPr>
+              <a:t>Most tools stop at a flat findings list. KubeGuard chains findings into ATT&amp;CK-tagged attack paths (narrative, never a runnable exploit), maps them to 9 frameworks with honest denominators, and exports auditor evidence — offline, read-only, zero telemetry.</a:t>
+            </a:r>
+            <a:endParaRPr lang="en-US" sz="1400" dirty="0"/>
+          </a:p>
+        </p:txBody>
+      </p:sp>
+      <p:sp>
+        <p:nvSpPr>
+          <p:cNvPr id="7" name="Shape 4"/>
+          <p:cNvSpPr/>
+          <p:nvPr/>
+        </p:nvSpPr>
+        <p:spPr>
+          <a:xfrm>
+            <a:off x="822960" y="2578608"/>
+            <a:ext cx="10515600" cy="886968"/>
+          </a:xfrm>
+          <a:prstGeom prst="rect">
+            <a:avLst/>
+          </a:prstGeom>
+          <a:solidFill>
+            <a:srgbClr val="FFFFFF"/>
+          </a:solidFill>
+          <a:ln w="12700">
+            <a:solidFill>
+              <a:srgbClr val="D7E0DE"/>
+            </a:solidFill>
+            <a:prstDash val="solid"/>
+          </a:ln>
+          <a:effectLst>
+            <a:outerShdw sx="100000" sy="100000" kx="0" ky="0" algn="bl" rotWithShape="0" blurRad="88900" dist="38100" dir="8100000">
+              <a:srgbClr val="0E2A2B">
+                <a:alpha val="12000"/>
+              </a:srgbClr>
+            </a:outerShdw>
+          </a:effectLst>
+        </p:spPr>
+      </p:sp>
+      <p:sp>
+        <p:nvSpPr>
+          <p:cNvPr id="8" name="Shape 5"/>
+          <p:cNvSpPr/>
+          <p:nvPr/>
+        </p:nvSpPr>
+        <p:spPr>
+          <a:xfrm>
+            <a:off x="822960" y="2578608"/>
+            <a:ext cx="109728" cy="886968"/>
+          </a:xfrm>
+          <a:prstGeom prst="rect">
+            <a:avLst/>
+          </a:prstGeom>
+          <a:solidFill>
+            <a:srgbClr val="F59E0B"/>
+          </a:solidFill>
+          <a:ln/>
+        </p:spPr>
+      </p:sp>
+      <p:sp>
+        <p:nvSpPr>
+          <p:cNvPr id="9" name="Text 6"/>
+          <p:cNvSpPr/>
+          <p:nvPr/>
+        </p:nvSpPr>
+        <p:spPr>
+          <a:xfrm>
+            <a:off x="1097280" y="2688336"/>
+            <a:ext cx="5852160" cy="365760"/>
+          </a:xfrm>
+          <a:prstGeom prst="rect">
+            <a:avLst/>
+          </a:prstGeom>
+          <a:noFill/>
+          <a:ln/>
+        </p:spPr>
+        <p:txBody>
+          <a:bodyPr wrap="square" lIns="0" tIns="0" rIns="0" bIns="0" rtlCol="0" anchor="ctr"/>
+          <a:lstStyle/>
+          <a:p>
+            <a:pPr indent="0" marL="0">
+              <a:buNone/>
+            </a:pPr>
+            <a:r>
+              <a:rPr lang="en-US" sz="1400" b="1" dirty="0">
+                <a:solidFill>
+                  <a:srgbClr val="0E2A2B"/>
+                </a:solidFill>
+                <a:latin typeface="Calibri" pitchFamily="34" charset="0"/>
+                <a:ea typeface="Calibri" pitchFamily="34" charset="-122"/>
+                <a:cs typeface="Calibri" pitchFamily="34" charset="-120"/>
+              </a:rPr>
+              <a:t>kube-bench · CIS benchmark tools</a:t>
+            </a:r>
+            <a:endParaRPr lang="en-US" sz="1400" dirty="0"/>
+          </a:p>
+        </p:txBody>
+      </p:sp>
+      <p:sp>
+        <p:nvSpPr>
+          <p:cNvPr id="10" name="Text 7"/>
+          <p:cNvSpPr/>
+          <p:nvPr/>
+        </p:nvSpPr>
+        <p:spPr>
+          <a:xfrm>
+            <a:off x="1097280" y="3035808"/>
+            <a:ext cx="5989320" cy="384048"/>
+          </a:xfrm>
+          <a:prstGeom prst="rect">
+            <a:avLst/>
+          </a:prstGeom>
+          <a:noFill/>
+          <a:ln/>
+        </p:spPr>
+        <p:txBody>
+          <a:bodyPr wrap="square" lIns="0" tIns="0" rIns="0" bIns="0" rtlCol="0" anchor="ctr"/>
+          <a:lstStyle/>
+          <a:p>
+            <a:pPr indent="0" marL="0">
+              <a:lnSpc>
+                <a:spcPct val="105000"/>
+              </a:lnSpc>
+              <a:buNone/>
+            </a:pPr>
+            <a:r>
+              <a:rPr lang="en-US" sz="1080" dirty="0">
+                <a:solidFill>
+                  <a:srgbClr val="475569"/>
+                </a:solidFill>
+                <a:latin typeface="Calibri" pitchFamily="34" charset="0"/>
+                <a:ea typeface="Calibri" pitchFamily="34" charset="-122"/>
+                <a:cs typeface="Calibri" pitchFamily="34" charset="-120"/>
+              </a:rPr>
+              <a:t>Node/host CIS checks — flat pass/fail, CIS-only, no attack chaining.</a:t>
+            </a:r>
+            <a:endParaRPr lang="en-US" sz="1080" dirty="0"/>
+          </a:p>
+        </p:txBody>
+      </p:sp>
+      <p:sp>
+        <p:nvSpPr>
+          <p:cNvPr id="11" name="Text 8"/>
+          <p:cNvSpPr/>
+          <p:nvPr/>
+        </p:nvSpPr>
+        <p:spPr>
+          <a:xfrm>
+            <a:off x="7178040" y="2871216"/>
+            <a:ext cx="4023360" cy="365760"/>
+          </a:xfrm>
+          <a:prstGeom prst="rect">
+            <a:avLst/>
+          </a:prstGeom>
+          <a:noFill/>
+          <a:ln/>
+        </p:spPr>
+        <p:txBody>
+          <a:bodyPr wrap="square" lIns="0" tIns="0" rIns="0" bIns="0" rtlCol="0" anchor="ctr"/>
+          <a:lstStyle/>
+          <a:p>
+            <a:pPr algn="r" indent="0" marL="0">
+              <a:buNone/>
+            </a:pPr>
+            <a:r>
+              <a:rPr lang="en-US" sz="1050" dirty="0">
+                <a:solidFill>
+                  <a:srgbClr val="0D9488"/>
+                </a:solidFill>
+                <a:latin typeface="Consolas" pitchFamily="34" charset="0"/>
+                <a:ea typeface="Consolas" pitchFamily="34" charset="-122"/>
+                <a:cs typeface="Consolas" pitchFamily="34" charset="-120"/>
+              </a:rPr>
+              <a:t>+ attack paths · 9 frameworks · evidence</a:t>
+            </a:r>
+            <a:endParaRPr lang="en-US" sz="1050" dirty="0"/>
+          </a:p>
+        </p:txBody>
+      </p:sp>
+      <p:sp>
+        <p:nvSpPr>
+          <p:cNvPr id="12" name="Shape 9"/>
+          <p:cNvSpPr/>
+          <p:nvPr/>
+        </p:nvSpPr>
+        <p:spPr>
+          <a:xfrm>
+            <a:off x="822960" y="3557016"/>
+            <a:ext cx="10515600" cy="886968"/>
+          </a:xfrm>
+          <a:prstGeom prst="rect">
+            <a:avLst/>
+          </a:prstGeom>
+          <a:solidFill>
+            <a:srgbClr val="FFFFFF"/>
+          </a:solidFill>
+          <a:ln w="12700">
+            <a:solidFill>
+              <a:srgbClr val="D7E0DE"/>
+            </a:solidFill>
+            <a:prstDash val="solid"/>
+          </a:ln>
+          <a:effectLst>
+            <a:outerShdw sx="100000" sy="100000" kx="0" ky="0" algn="bl" rotWithShape="0" blurRad="88900" dist="38100" dir="8100000">
+              <a:srgbClr val="0E2A2B">
+                <a:alpha val="12000"/>
+              </a:srgbClr>
+            </a:outerShdw>
+          </a:effectLst>
+        </p:spPr>
+      </p:sp>
+      <p:sp>
+        <p:nvSpPr>
+          <p:cNvPr id="13" name="Shape 10"/>
+          <p:cNvSpPr/>
+          <p:nvPr/>
+        </p:nvSpPr>
+        <p:spPr>
+          <a:xfrm>
+            <a:off x="822960" y="3557016"/>
+            <a:ext cx="109728" cy="886968"/>
+          </a:xfrm>
+          <a:prstGeom prst="rect">
+            <a:avLst/>
+          </a:prstGeom>
+          <a:solidFill>
+            <a:srgbClr val="F59E0B"/>
+          </a:solidFill>
+          <a:ln/>
+        </p:spPr>
+      </p:sp>
+      <p:sp>
+        <p:nvSpPr>
+          <p:cNvPr id="14" name="Text 11"/>
+          <p:cNvSpPr/>
+          <p:nvPr/>
+        </p:nvSpPr>
+        <p:spPr>
+          <a:xfrm>
+            <a:off x="1097280" y="3666744"/>
+            <a:ext cx="5852160" cy="365760"/>
+          </a:xfrm>
+          <a:prstGeom prst="rect">
+            <a:avLst/>
+          </a:prstGeom>
+          <a:noFill/>
+          <a:ln/>
+        </p:spPr>
+        <p:txBody>
+          <a:bodyPr wrap="square" lIns="0" tIns="0" rIns="0" bIns="0" rtlCol="0" anchor="ctr"/>
+          <a:lstStyle/>
+          <a:p>
+            <a:pPr indent="0" marL="0">
+              <a:buNone/>
+            </a:pPr>
+            <a:r>
+              <a:rPr lang="en-US" sz="1400" b="1" dirty="0">
+                <a:solidFill>
+                  <a:srgbClr val="0E2A2B"/>
+                </a:solidFill>
+                <a:latin typeface="Calibri" pitchFamily="34" charset="0"/>
+                <a:ea typeface="Calibri" pitchFamily="34" charset="-122"/>
+                <a:cs typeface="Calibri" pitchFamily="34" charset="-120"/>
+              </a:rPr>
+              <a:t>kubescape · control-framework scanners</a:t>
+            </a:r>
+            <a:endParaRPr lang="en-US" sz="1400" dirty="0"/>
+          </a:p>
+        </p:txBody>
+      </p:sp>
+      <p:sp>
+        <p:nvSpPr>
+          <p:cNvPr id="15" name="Text 12"/>
+          <p:cNvSpPr/>
+          <p:nvPr/>
+        </p:nvSpPr>
+        <p:spPr>
+          <a:xfrm>
+            <a:off x="1097280" y="4014216"/>
+            <a:ext cx="5989320" cy="384048"/>
+          </a:xfrm>
+          <a:prstGeom prst="rect">
+            <a:avLst/>
+          </a:prstGeom>
+          <a:noFill/>
+          <a:ln/>
+        </p:spPr>
+        <p:txBody>
+          <a:bodyPr wrap="square" lIns="0" tIns="0" rIns="0" bIns="0" rtlCol="0" anchor="ctr"/>
+          <a:lstStyle/>
+          <a:p>
+            <a:pPr indent="0" marL="0">
+              <a:lnSpc>
+                <a:spcPct val="105000"/>
+              </a:lnSpc>
+              <a:buNone/>
+            </a:pPr>
+            <a:r>
+              <a:rPr lang="en-US" sz="1080" dirty="0">
+                <a:solidFill>
+                  <a:srgbClr val="475569"/>
+                </a:solidFill>
+                <a:latin typeface="Calibri" pitchFamily="34" charset="0"/>
+                <a:ea typeface="Calibri" pitchFamily="34" charset="-122"/>
+                <a:cs typeface="Calibri" pitchFamily="34" charset="-120"/>
+              </a:rPr>
+              <a:t>NSA / MITRE / CIS control scores — but count everything; SaaS-leaning.</a:t>
+            </a:r>
+            <a:endParaRPr lang="en-US" sz="1080" dirty="0"/>
+          </a:p>
+        </p:txBody>
+      </p:sp>
+      <p:sp>
+        <p:nvSpPr>
+          <p:cNvPr id="16" name="Text 13"/>
+          <p:cNvSpPr/>
+          <p:nvPr/>
+        </p:nvSpPr>
+        <p:spPr>
+          <a:xfrm>
+            <a:off x="7178040" y="3849624"/>
+            <a:ext cx="4023360" cy="365760"/>
+          </a:xfrm>
+          <a:prstGeom prst="rect">
+            <a:avLst/>
+          </a:prstGeom>
+          <a:noFill/>
+          <a:ln/>
+        </p:spPr>
+        <p:txBody>
+          <a:bodyPr wrap="square" lIns="0" tIns="0" rIns="0" bIns="0" rtlCol="0" anchor="ctr"/>
+          <a:lstStyle/>
+          <a:p>
+            <a:pPr algn="r" indent="0" marL="0">
+              <a:buNone/>
+            </a:pPr>
+            <a:r>
+              <a:rPr lang="en-US" sz="1050" dirty="0">
+                <a:solidFill>
+                  <a:srgbClr val="0D9488"/>
+                </a:solidFill>
+                <a:latin typeface="Consolas" pitchFamily="34" charset="0"/>
+                <a:ea typeface="Consolas" pitchFamily="34" charset="-122"/>
+                <a:cs typeface="Consolas" pitchFamily="34" charset="-120"/>
+              </a:rPr>
+              <a:t>honest denominators · evidence packs</a:t>
+            </a:r>
+            <a:endParaRPr lang="en-US" sz="1050" dirty="0"/>
+          </a:p>
+        </p:txBody>
+      </p:sp>
+      <p:sp>
+        <p:nvSpPr>
+          <p:cNvPr id="17" name="Shape 14"/>
+          <p:cNvSpPr/>
+          <p:nvPr/>
+        </p:nvSpPr>
+        <p:spPr>
+          <a:xfrm>
+            <a:off x="822960" y="4535424"/>
+            <a:ext cx="10515600" cy="886968"/>
+          </a:xfrm>
+          <a:prstGeom prst="rect">
+            <a:avLst/>
+          </a:prstGeom>
+          <a:solidFill>
+            <a:srgbClr val="FFFFFF"/>
+          </a:solidFill>
+          <a:ln w="12700">
+            <a:solidFill>
+              <a:srgbClr val="D7E0DE"/>
+            </a:solidFill>
+            <a:prstDash val="solid"/>
+          </a:ln>
+          <a:effectLst>
+            <a:outerShdw sx="100000" sy="100000" kx="0" ky="0" algn="bl" rotWithShape="0" blurRad="88900" dist="38100" dir="8100000">
+              <a:srgbClr val="0E2A2B">
+                <a:alpha val="12000"/>
+              </a:srgbClr>
+            </a:outerShdw>
+          </a:effectLst>
+        </p:spPr>
+      </p:sp>
+      <p:sp>
+        <p:nvSpPr>
+          <p:cNvPr id="18" name="Shape 15"/>
+          <p:cNvSpPr/>
+          <p:nvPr/>
+        </p:nvSpPr>
+        <p:spPr>
+          <a:xfrm>
+            <a:off x="822960" y="4535424"/>
+            <a:ext cx="109728" cy="886968"/>
+          </a:xfrm>
+          <a:prstGeom prst="rect">
+            <a:avLst/>
+          </a:prstGeom>
+          <a:solidFill>
+            <a:srgbClr val="F59E0B"/>
+          </a:solidFill>
+          <a:ln/>
+        </p:spPr>
+      </p:sp>
+      <p:sp>
+        <p:nvSpPr>
+          <p:cNvPr id="19" name="Text 16"/>
+          <p:cNvSpPr/>
+          <p:nvPr/>
+        </p:nvSpPr>
+        <p:spPr>
+          <a:xfrm>
+            <a:off x="1097280" y="4645152"/>
+            <a:ext cx="5852160" cy="365760"/>
+          </a:xfrm>
+          <a:prstGeom prst="rect">
+            <a:avLst/>
+          </a:prstGeom>
+          <a:noFill/>
+          <a:ln/>
+        </p:spPr>
+        <p:txBody>
+          <a:bodyPr wrap="square" lIns="0" tIns="0" rIns="0" bIns="0" rtlCol="0" anchor="ctr"/>
+          <a:lstStyle/>
+          <a:p>
+            <a:pPr indent="0" marL="0">
+              <a:buNone/>
+            </a:pPr>
+            <a:r>
+              <a:rPr lang="en-US" sz="1400" b="1" dirty="0">
+                <a:solidFill>
+                  <a:srgbClr val="0E2A2B"/>
+                </a:solidFill>
+                <a:latin typeface="Calibri" pitchFamily="34" charset="0"/>
+                <a:ea typeface="Calibri" pitchFamily="34" charset="-122"/>
+                <a:cs typeface="Calibri" pitchFamily="34" charset="-120"/>
+              </a:rPr>
+              <a:t>Trivy · Checkov · kube-linter</a:t>
+            </a:r>
+            <a:endParaRPr lang="en-US" sz="1400" dirty="0"/>
+          </a:p>
+        </p:txBody>
+      </p:sp>
+      <p:sp>
+        <p:nvSpPr>
+          <p:cNvPr id="20" name="Text 17"/>
+          <p:cNvSpPr/>
+          <p:nvPr/>
+        </p:nvSpPr>
+        <p:spPr>
+          <a:xfrm>
+            <a:off x="1097280" y="4992624"/>
+            <a:ext cx="5989320" cy="384048"/>
+          </a:xfrm>
+          <a:prstGeom prst="rect">
+            <a:avLst/>
+          </a:prstGeom>
+          <a:noFill/>
+          <a:ln/>
+        </p:spPr>
+        <p:txBody>
+          <a:bodyPr wrap="square" lIns="0" tIns="0" rIns="0" bIns="0" rtlCol="0" anchor="ctr"/>
+          <a:lstStyle/>
+          <a:p>
+            <a:pPr indent="0" marL="0">
+              <a:lnSpc>
+                <a:spcPct val="105000"/>
+              </a:lnSpc>
+              <a:buNone/>
+            </a:pPr>
+            <a:r>
+              <a:rPr lang="en-US" sz="1080" dirty="0">
+                <a:solidFill>
+                  <a:srgbClr val="475569"/>
+                </a:solidFill>
+                <a:latin typeface="Calibri" pitchFamily="34" charset="0"/>
+                <a:ea typeface="Calibri" pitchFamily="34" charset="-122"/>
+                <a:cs typeface="Calibri" pitchFamily="34" charset="-120"/>
+              </a:rPr>
+              <a:t>Misconfig &amp; IaC lint — long flat finding lists, no exploit context.</a:t>
+            </a:r>
+            <a:endParaRPr lang="en-US" sz="1080" dirty="0"/>
+          </a:p>
+        </p:txBody>
+      </p:sp>
+      <p:sp>
+        <p:nvSpPr>
+          <p:cNvPr id="21" name="Text 18"/>
+          <p:cNvSpPr/>
+          <p:nvPr/>
+        </p:nvSpPr>
+        <p:spPr>
+          <a:xfrm>
+            <a:off x="7178040" y="4828032"/>
+            <a:ext cx="4023360" cy="365760"/>
+          </a:xfrm>
+          <a:prstGeom prst="rect">
+            <a:avLst/>
+          </a:prstGeom>
+          <a:noFill/>
+          <a:ln/>
+        </p:spPr>
+        <p:txBody>
+          <a:bodyPr wrap="square" lIns="0" tIns="0" rIns="0" bIns="0" rtlCol="0" anchor="ctr"/>
+          <a:lstStyle/>
+          <a:p>
+            <a:pPr algn="r" indent="0" marL="0">
+              <a:buNone/>
+            </a:pPr>
+            <a:r>
+              <a:rPr lang="en-US" sz="1050" dirty="0">
+                <a:solidFill>
+                  <a:srgbClr val="0D9488"/>
+                </a:solidFill>
+                <a:latin typeface="Consolas" pitchFamily="34" charset="0"/>
+                <a:ea typeface="Consolas" pitchFamily="34" charset="-122"/>
+                <a:cs typeface="Consolas" pitchFamily="34" charset="-120"/>
+              </a:rPr>
+              <a:t>capability-based ATT&amp;CK attack paths</a:t>
+            </a:r>
+            <a:endParaRPr lang="en-US" sz="1050" dirty="0"/>
+          </a:p>
+        </p:txBody>
+      </p:sp>
+      <p:sp>
+        <p:nvSpPr>
+          <p:cNvPr id="22" name="Shape 19"/>
+          <p:cNvSpPr/>
+          <p:nvPr/>
+        </p:nvSpPr>
+        <p:spPr>
+          <a:xfrm>
+            <a:off x="822960" y="5513832"/>
+            <a:ext cx="10515600" cy="886968"/>
+          </a:xfrm>
+          <a:prstGeom prst="rect">
+            <a:avLst/>
+          </a:prstGeom>
+          <a:solidFill>
+            <a:srgbClr val="FFFFFF"/>
+          </a:solidFill>
+          <a:ln w="12700">
+            <a:solidFill>
+              <a:srgbClr val="D7E0DE"/>
+            </a:solidFill>
+            <a:prstDash val="solid"/>
+          </a:ln>
+          <a:effectLst>
+            <a:outerShdw sx="100000" sy="100000" kx="0" ky="0" algn="bl" rotWithShape="0" blurRad="88900" dist="38100" dir="8100000">
+              <a:srgbClr val="0E2A2B">
+                <a:alpha val="12000"/>
+              </a:srgbClr>
+            </a:outerShdw>
+          </a:effectLst>
+        </p:spPr>
+      </p:sp>
+      <p:sp>
+        <p:nvSpPr>
+          <p:cNvPr id="23" name="Shape 20"/>
+          <p:cNvSpPr/>
+          <p:nvPr/>
+        </p:nvSpPr>
+        <p:spPr>
+          <a:xfrm>
+            <a:off x="822960" y="5513832"/>
+            <a:ext cx="109728" cy="886968"/>
+          </a:xfrm>
+          <a:prstGeom prst="rect">
+            <a:avLst/>
+          </a:prstGeom>
+          <a:solidFill>
+            <a:srgbClr val="F59E0B"/>
+          </a:solidFill>
+          <a:ln/>
+        </p:spPr>
+      </p:sp>
+      <p:sp>
+        <p:nvSpPr>
+          <p:cNvPr id="24" name="Text 21"/>
+          <p:cNvSpPr/>
+          <p:nvPr/>
+        </p:nvSpPr>
+        <p:spPr>
+          <a:xfrm>
+            <a:off x="1097280" y="5623560"/>
+            <a:ext cx="5852160" cy="365760"/>
+          </a:xfrm>
+          <a:prstGeom prst="rect">
+            <a:avLst/>
+          </a:prstGeom>
+          <a:noFill/>
+          <a:ln/>
+        </p:spPr>
+        <p:txBody>
+          <a:bodyPr wrap="square" lIns="0" tIns="0" rIns="0" bIns="0" rtlCol="0" anchor="ctr"/>
+          <a:lstStyle/>
+          <a:p>
+            <a:pPr indent="0" marL="0">
+              <a:buNone/>
+            </a:pPr>
+            <a:r>
+              <a:rPr lang="en-US" sz="1400" b="1" dirty="0">
+                <a:solidFill>
+                  <a:srgbClr val="0E2A2B"/>
+                </a:solidFill>
+                <a:latin typeface="Calibri" pitchFamily="34" charset="0"/>
+                <a:ea typeface="Calibri" pitchFamily="34" charset="-122"/>
+                <a:cs typeface="Calibri" pitchFamily="34" charset="-120"/>
+              </a:rPr>
+              <a:t>Wiz · Prisma · Aqua (CNAPP SaaS)</a:t>
+            </a:r>
+            <a:endParaRPr lang="en-US" sz="1400" dirty="0"/>
+          </a:p>
+        </p:txBody>
+      </p:sp>
+      <p:sp>
+        <p:nvSpPr>
+          <p:cNvPr id="25" name="Text 22"/>
+          <p:cNvSpPr/>
+          <p:nvPr/>
+        </p:nvSpPr>
+        <p:spPr>
+          <a:xfrm>
+            <a:off x="1097280" y="5971032"/>
+            <a:ext cx="5989320" cy="384048"/>
+          </a:xfrm>
+          <a:prstGeom prst="rect">
+            <a:avLst/>
+          </a:prstGeom>
+          <a:noFill/>
+          <a:ln/>
+        </p:spPr>
+        <p:txBody>
+          <a:bodyPr wrap="square" lIns="0" tIns="0" rIns="0" bIns="0" rtlCol="0" anchor="ctr"/>
+          <a:lstStyle/>
+          <a:p>
+            <a:pPr indent="0" marL="0">
+              <a:lnSpc>
+                <a:spcPct val="105000"/>
+              </a:lnSpc>
+              <a:buNone/>
+            </a:pPr>
+            <a:r>
+              <a:rPr lang="en-US" sz="1080" dirty="0">
+                <a:solidFill>
+                  <a:srgbClr val="475569"/>
+                </a:solidFill>
+                <a:latin typeface="Calibri" pitchFamily="34" charset="0"/>
+                <a:ea typeface="Calibri" pitchFamily="34" charset="-122"/>
+                <a:cs typeface="Calibri" pitchFamily="34" charset="-120"/>
+              </a:rPr>
+              <a:t>Agent-heavy; exfiltrate posture to vendor cloud; per-asset pricing.</a:t>
+            </a:r>
+            <a:endParaRPr lang="en-US" sz="1080" dirty="0"/>
+          </a:p>
+        </p:txBody>
+      </p:sp>
+      <p:sp>
+        <p:nvSpPr>
+          <p:cNvPr id="26" name="Text 23"/>
+          <p:cNvSpPr/>
+          <p:nvPr/>
+        </p:nvSpPr>
+        <p:spPr>
+          <a:xfrm>
+            <a:off x="7178040" y="5806440"/>
+            <a:ext cx="4023360" cy="365760"/>
+          </a:xfrm>
+          <a:prstGeom prst="rect">
+            <a:avLst/>
+          </a:prstGeom>
+          <a:noFill/>
+          <a:ln/>
+        </p:spPr>
+        <p:txBody>
+          <a:bodyPr wrap="square" lIns="0" tIns="0" rIns="0" bIns="0" rtlCol="0" anchor="ctr"/>
+          <a:lstStyle/>
+          <a:p>
+            <a:pPr algn="r" indent="0" marL="0">
+              <a:buNone/>
+            </a:pPr>
+            <a:r>
+              <a:rPr lang="en-US" sz="1050" dirty="0">
+                <a:solidFill>
+                  <a:srgbClr val="0D9488"/>
+                </a:solidFill>
+                <a:latin typeface="Consolas" pitchFamily="34" charset="0"/>
+                <a:ea typeface="Consolas" pitchFamily="34" charset="-122"/>
+                <a:cs typeface="Consolas" pitchFamily="34" charset="-120"/>
+              </a:rPr>
+              <a:t>offline · zero telemetry · self-hosted</a:t>
+            </a:r>
+            <a:endParaRPr lang="en-US" sz="1050" dirty="0"/>
+          </a:p>
+        </p:txBody>
+      </p:sp>
+    </p:spTree>
+  </p:cSld>
+  <p:clrMapOvr>
+    <a:masterClrMapping/>
+  </p:clrMapOvr>
+</p:sld>
+</file>
+
+<file path=ppt/slides/slide13.xml><?xml version="1.0" encoding="utf-8"?>
+<p:sld xmlns:a="http://schemas.openxmlformats.org/drawingml/2006/main" xmlns:r="http://schemas.openxmlformats.org/officeDocument/2006/relationships" xmlns:p="http://schemas.openxmlformats.org/presentationml/2006/main">
+  <p:cSld name="Slide 9">
+    <p:bg>
+      <p:bgPr>
+        <a:solidFill>
+          <a:srgbClr val="FFFFFF"/>
+        </a:solidFill>
+      </p:bgPr>
+    </p:bg>
+    <p:spTree>
+      <p:nvGrpSpPr>
+        <p:cNvPr id="1" name=""/>
+        <p:cNvGrpSpPr/>
+        <p:nvPr/>
+      </p:nvGrpSpPr>
+      <p:grpSpPr>
+        <a:xfrm>
+          <a:off x="0" y="0"/>
+          <a:ext cx="0" cy="0"/>
+          <a:chOff x="0" y="0"/>
+          <a:chExt cx="0" cy="0"/>
+        </a:xfrm>
+      </p:grpSpPr>
+      <p:sp>
+        <p:nvSpPr>
+          <p:cNvPr id="2" name="Text 0"/>
+          <p:cNvSpPr/>
+          <p:nvPr/>
+        </p:nvSpPr>
+        <p:spPr>
+          <a:xfrm>
+            <a:off x="822960" y="502920"/>
+            <a:ext cx="10515600" cy="274320"/>
+          </a:xfrm>
+          <a:prstGeom prst="rect">
+            <a:avLst/>
+          </a:prstGeom>
+          <a:noFill/>
+          <a:ln/>
+        </p:spPr>
+        <p:txBody>
+          <a:bodyPr wrap="square" lIns="0" tIns="0" rIns="0" bIns="0" rtlCol="0" anchor="ctr"/>
+          <a:lstStyle/>
+          <a:p>
+            <a:pPr indent="0" marL="0">
+              <a:buNone/>
+            </a:pPr>
+            <a:r>
+              <a:rPr lang="en-US" sz="1200" b="1" spc="300" kern="0" dirty="0">
+                <a:solidFill>
+                  <a:srgbClr val="F59E0B"/>
+                </a:solidFill>
+                <a:latin typeface="Calibri" pitchFamily="34" charset="0"/>
+                <a:ea typeface="Calibri" pitchFamily="34" charset="-122"/>
+                <a:cs typeface="Calibri" pitchFamily="34" charset="-120"/>
+              </a:rPr>
+              <a:t>THE BUSINESS CASE</a:t>
+            </a:r>
+            <a:endParaRPr lang="en-US" sz="1200" dirty="0"/>
+          </a:p>
+        </p:txBody>
+      </p:sp>
+      <p:sp>
+        <p:nvSpPr>
+          <p:cNvPr id="3" name="Text 1"/>
+          <p:cNvSpPr/>
+          <p:nvPr/>
+        </p:nvSpPr>
+        <p:spPr>
+          <a:xfrm>
+            <a:off x="822960" y="777240"/>
+            <a:ext cx="10515600" cy="777240"/>
+          </a:xfrm>
+          <a:prstGeom prst="rect">
+            <a:avLst/>
+          </a:prstGeom>
+          <a:noFill/>
+          <a:ln/>
+        </p:spPr>
+        <p:txBody>
+          <a:bodyPr wrap="square" lIns="0" tIns="0" rIns="0" bIns="0" rtlCol="0" anchor="ctr"/>
+          <a:lstStyle/>
+          <a:p>
+            <a:pPr indent="0" marL="0">
+              <a:buNone/>
+            </a:pPr>
+            <a:r>
+              <a:rPr lang="en-US" sz="3000" b="1" dirty="0">
+                <a:solidFill>
+                  <a:srgbClr val="0E2A2B"/>
+                </a:solidFill>
+                <a:latin typeface="Georgia" pitchFamily="34" charset="0"/>
+                <a:ea typeface="Georgia" pitchFamily="34" charset="-122"/>
+                <a:cs typeface="Georgia" pitchFamily="34" charset="-120"/>
+              </a:rPr>
+              <a:t>What it saves — and earns</a:t>
+            </a:r>
+            <a:endParaRPr lang="en-US" sz="3000" dirty="0"/>
+          </a:p>
+        </p:txBody>
+      </p:sp>
+      <p:sp>
+        <p:nvSpPr>
+          <p:cNvPr id="4" name="Text 2"/>
+          <p:cNvSpPr/>
+          <p:nvPr/>
+        </p:nvSpPr>
+        <p:spPr>
+          <a:xfrm>
+            <a:off x="822960" y="1417320"/>
+            <a:ext cx="10515600" cy="548640"/>
+          </a:xfrm>
+          <a:prstGeom prst="rect">
+            <a:avLst/>
+          </a:prstGeom>
+          <a:noFill/>
+          <a:ln/>
+        </p:spPr>
+        <p:txBody>
+          <a:bodyPr wrap="square" lIns="0" tIns="0" rIns="0" bIns="0" rtlCol="0" anchor="ctr"/>
+          <a:lstStyle/>
+          <a:p>
+            <a:pPr indent="0" marL="0">
+              <a:lnSpc>
+                <a:spcPct val="115000"/>
+              </a:lnSpc>
+              <a:buNone/>
+            </a:pPr>
+            <a:r>
+              <a:rPr lang="en-US" sz="1400" dirty="0">
+                <a:solidFill>
+                  <a:srgbClr val="475569"/>
+                </a:solidFill>
+                <a:latin typeface="Calibri" pitchFamily="34" charset="0"/>
+                <a:ea typeface="Calibri" pitchFamily="34" charset="-122"/>
+                <a:cs typeface="Calibri" pitchFamily="34" charset="-120"/>
+              </a:rPr>
+              <a:t>Four ways the same scan pays back. Ranges are illustrative for a mid-size estate (~200 workloads) — replace them with your own numbers.</a:t>
+            </a:r>
+            <a:endParaRPr lang="en-US" sz="1400" dirty="0"/>
+          </a:p>
+        </p:txBody>
+      </p:sp>
+      <p:sp>
+        <p:nvSpPr>
+          <p:cNvPr id="5" name="Shape 3"/>
+          <p:cNvSpPr/>
+          <p:nvPr/>
+        </p:nvSpPr>
+        <p:spPr>
+          <a:xfrm>
+            <a:off x="822960" y="2194560"/>
+            <a:ext cx="5212080" cy="1691640"/>
+          </a:xfrm>
+          <a:prstGeom prst="rect">
+            <a:avLst/>
+          </a:prstGeom>
+          <a:solidFill>
+            <a:srgbClr val="F1F5F4"/>
+          </a:solidFill>
+          <a:ln w="12700">
+            <a:solidFill>
+              <a:srgbClr val="D7E0DE"/>
+            </a:solidFill>
+            <a:prstDash val="solid"/>
+          </a:ln>
+          <a:effectLst>
+            <a:outerShdw sx="100000" sy="100000" kx="0" ky="0" algn="bl" rotWithShape="0" blurRad="88900" dist="38100" dir="8100000">
+              <a:srgbClr val="0E2A2B">
+                <a:alpha val="12000"/>
+              </a:srgbClr>
+            </a:outerShdw>
+          </a:effectLst>
+        </p:spPr>
+      </p:sp>
+      <p:sp>
+        <p:nvSpPr>
+          <p:cNvPr id="6" name="Shape 4"/>
+          <p:cNvSpPr/>
+          <p:nvPr/>
+        </p:nvSpPr>
+        <p:spPr>
+          <a:xfrm>
+            <a:off x="822960" y="2194560"/>
+            <a:ext cx="5212080" cy="109728"/>
+          </a:xfrm>
+          <a:prstGeom prst="rect">
+            <a:avLst/>
+          </a:prstGeom>
+          <a:solidFill>
+            <a:srgbClr val="0D9488"/>
+          </a:solidFill>
+          <a:ln/>
+        </p:spPr>
+      </p:sp>
+      <p:sp>
+        <p:nvSpPr>
+          <p:cNvPr id="7" name="Text 5"/>
+          <p:cNvSpPr/>
+          <p:nvPr/>
+        </p:nvSpPr>
+        <p:spPr>
+          <a:xfrm>
+            <a:off x="1115568" y="2450592"/>
+            <a:ext cx="4663440" cy="365760"/>
+          </a:xfrm>
+          <a:prstGeom prst="rect">
+            <a:avLst/>
+          </a:prstGeom>
+          <a:noFill/>
+          <a:ln/>
+        </p:spPr>
+        <p:txBody>
+          <a:bodyPr wrap="square" lIns="0" tIns="0" rIns="0" bIns="0" rtlCol="0" anchor="ctr"/>
+          <a:lstStyle/>
+          <a:p>
+            <a:pPr indent="0" marL="0">
+              <a:buNone/>
+            </a:pPr>
+            <a:r>
+              <a:rPr lang="en-US" sz="1600" b="1" dirty="0">
+                <a:solidFill>
+                  <a:srgbClr val="0E2A2B"/>
+                </a:solidFill>
+                <a:latin typeface="Calibri" pitchFamily="34" charset="0"/>
+                <a:ea typeface="Calibri" pitchFamily="34" charset="-122"/>
+                <a:cs typeface="Calibri" pitchFamily="34" charset="-120"/>
+              </a:rPr>
+              <a:t>Audit evidence prep</a:t>
+            </a:r>
+            <a:endParaRPr lang="en-US" sz="1600" dirty="0"/>
+          </a:p>
+        </p:txBody>
+      </p:sp>
+      <p:sp>
+        <p:nvSpPr>
+          <p:cNvPr id="8" name="Text 6"/>
+          <p:cNvSpPr/>
+          <p:nvPr/>
+        </p:nvSpPr>
+        <p:spPr>
+          <a:xfrm>
+            <a:off x="1115568" y="2907792"/>
+            <a:ext cx="4663440" cy="640080"/>
+          </a:xfrm>
+          <a:prstGeom prst="rect">
+            <a:avLst/>
+          </a:prstGeom>
+          <a:noFill/>
+          <a:ln/>
+        </p:spPr>
+        <p:txBody>
+          <a:bodyPr wrap="square" lIns="0" tIns="0" rIns="0" bIns="0" rtlCol="0" anchor="ctr"/>
+          <a:lstStyle/>
+          <a:p>
+            <a:pPr indent="0" marL="0">
+              <a:lnSpc>
+                <a:spcPct val="112000"/>
+              </a:lnSpc>
+              <a:buNone/>
+            </a:pPr>
+            <a:r>
+              <a:rPr lang="en-US" sz="1200" dirty="0">
+                <a:solidFill>
+                  <a:srgbClr val="475569"/>
+                </a:solidFill>
+                <a:latin typeface="Calibri" pitchFamily="34" charset="0"/>
+                <a:ea typeface="Calibri" pitchFamily="34" charset="-122"/>
+                <a:cs typeface="Calibri" pitchFamily="34" charset="-120"/>
+              </a:rPr>
+              <a:t>Auto-generated per-framework evidence packs replace manual screenshot &amp; spreadsheet collection.</a:t>
+            </a:r>
+            <a:endParaRPr lang="en-US" sz="1200" dirty="0"/>
+          </a:p>
+        </p:txBody>
+      </p:sp>
+      <p:sp>
+        <p:nvSpPr>
+          <p:cNvPr id="9" name="Text 7"/>
+          <p:cNvSpPr/>
+          <p:nvPr/>
+        </p:nvSpPr>
+        <p:spPr>
+          <a:xfrm>
+            <a:off x="1115568" y="3520440"/>
+            <a:ext cx="4663440" cy="274320"/>
+          </a:xfrm>
+          <a:prstGeom prst="rect">
+            <a:avLst/>
+          </a:prstGeom>
+          <a:noFill/>
+          <a:ln/>
+        </p:spPr>
+        <p:txBody>
+          <a:bodyPr wrap="square" lIns="0" tIns="0" rIns="0" bIns="0" rtlCol="0" anchor="ctr"/>
+          <a:lstStyle/>
+          <a:p>
+            <a:pPr indent="0" marL="0">
+              <a:buNone/>
+            </a:pPr>
+            <a:r>
+              <a:rPr lang="en-US" sz="1100" dirty="0">
+                <a:solidFill>
+                  <a:srgbClr val="0D9488"/>
+                </a:solidFill>
+                <a:latin typeface="Consolas" pitchFamily="34" charset="0"/>
+                <a:ea typeface="Consolas" pitchFamily="34" charset="-122"/>
+                <a:cs typeface="Consolas" pitchFamily="34" charset="-120"/>
+              </a:rPr>
+              <a:t>≈ £10k–60k / yr</a:t>
+            </a:r>
+            <a:endParaRPr lang="en-US" sz="1100" dirty="0"/>
+          </a:p>
+        </p:txBody>
+      </p:sp>
+      <p:sp>
+        <p:nvSpPr>
+          <p:cNvPr id="10" name="Shape 8"/>
+          <p:cNvSpPr/>
+          <p:nvPr/>
+        </p:nvSpPr>
+        <p:spPr>
+          <a:xfrm>
+            <a:off x="6263640" y="2194560"/>
+            <a:ext cx="5212080" cy="1691640"/>
+          </a:xfrm>
+          <a:prstGeom prst="rect">
+            <a:avLst/>
+          </a:prstGeom>
+          <a:solidFill>
+            <a:srgbClr val="F1F5F4"/>
+          </a:solidFill>
+          <a:ln w="12700">
+            <a:solidFill>
+              <a:srgbClr val="D7E0DE"/>
+            </a:solidFill>
+            <a:prstDash val="solid"/>
+          </a:ln>
+          <a:effectLst>
+            <a:outerShdw sx="100000" sy="100000" kx="0" ky="0" algn="bl" rotWithShape="0" blurRad="88900" dist="38100" dir="8100000">
+              <a:srgbClr val="0E2A2B">
+                <a:alpha val="12000"/>
+              </a:srgbClr>
+            </a:outerShdw>
+          </a:effectLst>
+        </p:spPr>
+      </p:sp>
+      <p:sp>
+        <p:nvSpPr>
+          <p:cNvPr id="11" name="Shape 9"/>
+          <p:cNvSpPr/>
+          <p:nvPr/>
+        </p:nvSpPr>
+        <p:spPr>
+          <a:xfrm>
+            <a:off x="6263640" y="2194560"/>
+            <a:ext cx="5212080" cy="109728"/>
+          </a:xfrm>
+          <a:prstGeom prst="rect">
+            <a:avLst/>
+          </a:prstGeom>
+          <a:solidFill>
+            <a:srgbClr val="0D9488"/>
+          </a:solidFill>
+          <a:ln/>
+        </p:spPr>
+      </p:sp>
+      <p:sp>
+        <p:nvSpPr>
+          <p:cNvPr id="12" name="Text 10"/>
+          <p:cNvSpPr/>
+          <p:nvPr/>
+        </p:nvSpPr>
+        <p:spPr>
+          <a:xfrm>
+            <a:off x="6556248" y="2450592"/>
+            <a:ext cx="4663440" cy="365760"/>
+          </a:xfrm>
+          <a:prstGeom prst="rect">
+            <a:avLst/>
+          </a:prstGeom>
+          <a:noFill/>
+          <a:ln/>
+        </p:spPr>
+        <p:txBody>
+          <a:bodyPr wrap="square" lIns="0" tIns="0" rIns="0" bIns="0" rtlCol="0" anchor="ctr"/>
+          <a:lstStyle/>
+          <a:p>
+            <a:pPr indent="0" marL="0">
+              <a:buNone/>
+            </a:pPr>
+            <a:r>
+              <a:rPr lang="en-US" sz="1600" b="1" dirty="0">
+                <a:solidFill>
+                  <a:srgbClr val="0E2A2B"/>
+                </a:solidFill>
+                <a:latin typeface="Calibri" pitchFamily="34" charset="0"/>
+                <a:ea typeface="Calibri" pitchFamily="34" charset="-122"/>
+                <a:cs typeface="Calibri" pitchFamily="34" charset="-120"/>
+              </a:rPr>
+              <a:t>Tool consolidation</a:t>
+            </a:r>
+            <a:endParaRPr lang="en-US" sz="1600" dirty="0"/>
+          </a:p>
+        </p:txBody>
+      </p:sp>
+      <p:sp>
+        <p:nvSpPr>
+          <p:cNvPr id="13" name="Text 11"/>
+          <p:cNvSpPr/>
+          <p:nvPr/>
+        </p:nvSpPr>
+        <p:spPr>
+          <a:xfrm>
+            <a:off x="6556248" y="2907792"/>
+            <a:ext cx="4663440" cy="640080"/>
+          </a:xfrm>
+          <a:prstGeom prst="rect">
+            <a:avLst/>
+          </a:prstGeom>
+          <a:noFill/>
+          <a:ln/>
+        </p:spPr>
+        <p:txBody>
+          <a:bodyPr wrap="square" lIns="0" tIns="0" rIns="0" bIns="0" rtlCol="0" anchor="ctr"/>
+          <a:lstStyle/>
+          <a:p>
+            <a:pPr indent="0" marL="0">
+              <a:lnSpc>
+                <a:spcPct val="112000"/>
+              </a:lnSpc>
+              <a:buNone/>
+            </a:pPr>
+            <a:r>
+              <a:rPr lang="en-US" sz="1200" dirty="0">
+                <a:solidFill>
+                  <a:srgbClr val="475569"/>
+                </a:solidFill>
+                <a:latin typeface="Calibri" pitchFamily="34" charset="0"/>
+                <a:ea typeface="Calibri" pitchFamily="34" charset="-122"/>
+                <a:cs typeface="Calibri" pitchFamily="34" charset="-120"/>
+              </a:rPr>
+              <a:t>Agentless — folds in point tools and avoids per-asset CNAPP SaaS seats and agent overhead.</a:t>
+            </a:r>
+            <a:endParaRPr lang="en-US" sz="1200" dirty="0"/>
+          </a:p>
+        </p:txBody>
+      </p:sp>
+      <p:sp>
+        <p:nvSpPr>
+          <p:cNvPr id="14" name="Text 12"/>
+          <p:cNvSpPr/>
+          <p:nvPr/>
+        </p:nvSpPr>
+        <p:spPr>
+          <a:xfrm>
+            <a:off x="6556248" y="3520440"/>
+            <a:ext cx="4663440" cy="274320"/>
+          </a:xfrm>
+          <a:prstGeom prst="rect">
+            <a:avLst/>
+          </a:prstGeom>
+          <a:noFill/>
+          <a:ln/>
+        </p:spPr>
+        <p:txBody>
+          <a:bodyPr wrap="square" lIns="0" tIns="0" rIns="0" bIns="0" rtlCol="0" anchor="ctr"/>
+          <a:lstStyle/>
+          <a:p>
+            <a:pPr indent="0" marL="0">
+              <a:buNone/>
+            </a:pPr>
+            <a:r>
+              <a:rPr lang="en-US" sz="1100" dirty="0">
+                <a:solidFill>
+                  <a:srgbClr val="0D9488"/>
+                </a:solidFill>
+                <a:latin typeface="Consolas" pitchFamily="34" charset="0"/>
+                <a:ea typeface="Consolas" pitchFamily="34" charset="-122"/>
+                <a:cs typeface="Consolas" pitchFamily="34" charset="-120"/>
+              </a:rPr>
+              <a:t>CNAPP SaaS ≈ £60k–250k+/yr</a:t>
+            </a:r>
+            <a:endParaRPr lang="en-US" sz="1100" dirty="0"/>
+          </a:p>
+        </p:txBody>
+      </p:sp>
+      <p:sp>
+        <p:nvSpPr>
+          <p:cNvPr id="15" name="Shape 13"/>
+          <p:cNvSpPr/>
+          <p:nvPr/>
+        </p:nvSpPr>
+        <p:spPr>
+          <a:xfrm>
+            <a:off x="822960" y="4069080"/>
+            <a:ext cx="5212080" cy="1691640"/>
+          </a:xfrm>
+          <a:prstGeom prst="rect">
+            <a:avLst/>
+          </a:prstGeom>
+          <a:solidFill>
+            <a:srgbClr val="F1F5F4"/>
+          </a:solidFill>
+          <a:ln w="12700">
+            <a:solidFill>
+              <a:srgbClr val="D7E0DE"/>
+            </a:solidFill>
+            <a:prstDash val="solid"/>
+          </a:ln>
+          <a:effectLst>
+            <a:outerShdw sx="100000" sy="100000" kx="0" ky="0" algn="bl" rotWithShape="0" blurRad="88900" dist="38100" dir="8100000">
+              <a:srgbClr val="0E2A2B">
+                <a:alpha val="12000"/>
+              </a:srgbClr>
+            </a:outerShdw>
+          </a:effectLst>
+        </p:spPr>
+      </p:sp>
+      <p:sp>
+        <p:nvSpPr>
+          <p:cNvPr id="16" name="Shape 14"/>
+          <p:cNvSpPr/>
+          <p:nvPr/>
+        </p:nvSpPr>
+        <p:spPr>
+          <a:xfrm>
+            <a:off x="822960" y="4069080"/>
+            <a:ext cx="5212080" cy="109728"/>
+          </a:xfrm>
+          <a:prstGeom prst="rect">
+            <a:avLst/>
+          </a:prstGeom>
+          <a:solidFill>
+            <a:srgbClr val="0D9488"/>
+          </a:solidFill>
+          <a:ln/>
+        </p:spPr>
+      </p:sp>
+      <p:sp>
+        <p:nvSpPr>
+          <p:cNvPr id="17" name="Text 15"/>
+          <p:cNvSpPr/>
+          <p:nvPr/>
+        </p:nvSpPr>
+        <p:spPr>
+          <a:xfrm>
+            <a:off x="1115568" y="4325112"/>
+            <a:ext cx="4663440" cy="365760"/>
+          </a:xfrm>
+          <a:prstGeom prst="rect">
+            <a:avLst/>
+          </a:prstGeom>
+          <a:noFill/>
+          <a:ln/>
+        </p:spPr>
+        <p:txBody>
+          <a:bodyPr wrap="square" lIns="0" tIns="0" rIns="0" bIns="0" rtlCol="0" anchor="ctr"/>
+          <a:lstStyle/>
+          <a:p>
+            <a:pPr indent="0" marL="0">
+              <a:buNone/>
+            </a:pPr>
+            <a:r>
+              <a:rPr lang="en-US" sz="1600" b="1" dirty="0">
+                <a:solidFill>
+                  <a:srgbClr val="0E2A2B"/>
+                </a:solidFill>
+                <a:latin typeface="Calibri" pitchFamily="34" charset="0"/>
+                <a:ea typeface="Calibri" pitchFamily="34" charset="-122"/>
+                <a:cs typeface="Calibri" pitchFamily="34" charset="-120"/>
+              </a:rPr>
+              <a:t>Breach expected-loss</a:t>
+            </a:r>
+            <a:endParaRPr lang="en-US" sz="1600" dirty="0"/>
+          </a:p>
+        </p:txBody>
+      </p:sp>
+      <p:sp>
+        <p:nvSpPr>
+          <p:cNvPr id="18" name="Text 16"/>
+          <p:cNvSpPr/>
+          <p:nvPr/>
+        </p:nvSpPr>
+        <p:spPr>
+          <a:xfrm>
+            <a:off x="1115568" y="4782312"/>
+            <a:ext cx="4663440" cy="640080"/>
+          </a:xfrm>
+          <a:prstGeom prst="rect">
+            <a:avLst/>
+          </a:prstGeom>
+          <a:noFill/>
+          <a:ln/>
+        </p:spPr>
+        <p:txBody>
+          <a:bodyPr wrap="square" lIns="0" tIns="0" rIns="0" bIns="0" rtlCol="0" anchor="ctr"/>
+          <a:lstStyle/>
+          <a:p>
+            <a:pPr indent="0" marL="0">
+              <a:lnSpc>
+                <a:spcPct val="112000"/>
+              </a:lnSpc>
+              <a:buNone/>
+            </a:pPr>
+            <a:r>
+              <a:rPr lang="en-US" sz="1200" dirty="0">
+                <a:solidFill>
+                  <a:srgbClr val="475569"/>
+                </a:solidFill>
+                <a:latin typeface="Calibri" pitchFamily="34" charset="0"/>
+                <a:ea typeface="Calibri" pitchFamily="34" charset="-122"/>
+                <a:cs typeface="Calibri" pitchFamily="34" charset="-120"/>
+              </a:rPr>
+              <a:t>Attack-path priority fixes the chains that actually reach cluster-admin first, cutting breach odds.</a:t>
+            </a:r>
+            <a:endParaRPr lang="en-US" sz="1200" dirty="0"/>
+          </a:p>
+        </p:txBody>
+      </p:sp>
+      <p:sp>
+        <p:nvSpPr>
+          <p:cNvPr id="19" name="Text 17"/>
+          <p:cNvSpPr/>
+          <p:nvPr/>
+        </p:nvSpPr>
+        <p:spPr>
+          <a:xfrm>
+            <a:off x="1115568" y="5394960"/>
+            <a:ext cx="4663440" cy="274320"/>
+          </a:xfrm>
+          <a:prstGeom prst="rect">
+            <a:avLst/>
+          </a:prstGeom>
+          <a:noFill/>
+          <a:ln/>
+        </p:spPr>
+        <p:txBody>
+          <a:bodyPr wrap="square" lIns="0" tIns="0" rIns="0" bIns="0" rtlCol="0" anchor="ctr"/>
+          <a:lstStyle/>
+          <a:p>
+            <a:pPr indent="0" marL="0">
+              <a:buNone/>
+            </a:pPr>
+            <a:r>
+              <a:rPr lang="en-US" sz="1100" dirty="0">
+                <a:solidFill>
+                  <a:srgbClr val="0D9488"/>
+                </a:solidFill>
+                <a:latin typeface="Consolas" pitchFamily="34" charset="0"/>
+                <a:ea typeface="Consolas" pitchFamily="34" charset="-122"/>
+                <a:cs typeface="Consolas" pitchFamily="34" charset="-120"/>
+              </a:rPr>
+              <a:t>1% × ~£3–4M ≈ £30–40k EV</a:t>
+            </a:r>
+            <a:endParaRPr lang="en-US" sz="1100" dirty="0"/>
+          </a:p>
+        </p:txBody>
+      </p:sp>
+      <p:sp>
+        <p:nvSpPr>
+          <p:cNvPr id="20" name="Shape 18"/>
+          <p:cNvSpPr/>
+          <p:nvPr/>
+        </p:nvSpPr>
+        <p:spPr>
+          <a:xfrm>
+            <a:off x="6263640" y="4069080"/>
+            <a:ext cx="5212080" cy="1691640"/>
+          </a:xfrm>
+          <a:prstGeom prst="rect">
+            <a:avLst/>
+          </a:prstGeom>
+          <a:solidFill>
+            <a:srgbClr val="F1F5F4"/>
+          </a:solidFill>
+          <a:ln w="12700">
+            <a:solidFill>
+              <a:srgbClr val="D7E0DE"/>
+            </a:solidFill>
+            <a:prstDash val="solid"/>
+          </a:ln>
+          <a:effectLst>
+            <a:outerShdw sx="100000" sy="100000" kx="0" ky="0" algn="bl" rotWithShape="0" blurRad="88900" dist="38100" dir="8100000">
+              <a:srgbClr val="0E2A2B">
+                <a:alpha val="12000"/>
+              </a:srgbClr>
+            </a:outerShdw>
+          </a:effectLst>
+        </p:spPr>
+      </p:sp>
+      <p:sp>
+        <p:nvSpPr>
+          <p:cNvPr id="21" name="Shape 19"/>
+          <p:cNvSpPr/>
+          <p:nvPr/>
+        </p:nvSpPr>
+        <p:spPr>
+          <a:xfrm>
+            <a:off x="6263640" y="4069080"/>
+            <a:ext cx="5212080" cy="109728"/>
+          </a:xfrm>
+          <a:prstGeom prst="rect">
+            <a:avLst/>
+          </a:prstGeom>
+          <a:solidFill>
+            <a:srgbClr val="0D9488"/>
+          </a:solidFill>
+          <a:ln/>
+        </p:spPr>
+      </p:sp>
+      <p:sp>
+        <p:nvSpPr>
+          <p:cNvPr id="22" name="Text 20"/>
+          <p:cNvSpPr/>
+          <p:nvPr/>
+        </p:nvSpPr>
+        <p:spPr>
+          <a:xfrm>
+            <a:off x="6556248" y="4325112"/>
+            <a:ext cx="4663440" cy="365760"/>
+          </a:xfrm>
+          <a:prstGeom prst="rect">
+            <a:avLst/>
+          </a:prstGeom>
+          <a:noFill/>
+          <a:ln/>
+        </p:spPr>
+        <p:txBody>
+          <a:bodyPr wrap="square" lIns="0" tIns="0" rIns="0" bIns="0" rtlCol="0" anchor="ctr"/>
+          <a:lstStyle/>
+          <a:p>
+            <a:pPr indent="0" marL="0">
+              <a:buNone/>
+            </a:pPr>
+            <a:r>
+              <a:rPr lang="en-US" sz="1600" b="1" dirty="0">
+                <a:solidFill>
+                  <a:srgbClr val="0E2A2B"/>
+                </a:solidFill>
+                <a:latin typeface="Calibri" pitchFamily="34" charset="0"/>
+                <a:ea typeface="Calibri" pitchFamily="34" charset="-122"/>
+                <a:cs typeface="Calibri" pitchFamily="34" charset="-120"/>
+              </a:rPr>
+              <a:t>Revenue enablement</a:t>
+            </a:r>
+            <a:endParaRPr lang="en-US" sz="1600" dirty="0"/>
+          </a:p>
+        </p:txBody>
+      </p:sp>
+      <p:sp>
+        <p:nvSpPr>
+          <p:cNvPr id="23" name="Text 21"/>
+          <p:cNvSpPr/>
+          <p:nvPr/>
+        </p:nvSpPr>
+        <p:spPr>
+          <a:xfrm>
+            <a:off x="6556248" y="4782312"/>
+            <a:ext cx="4663440" cy="640080"/>
+          </a:xfrm>
+          <a:prstGeom prst="rect">
+            <a:avLst/>
+          </a:prstGeom>
+          <a:noFill/>
+          <a:ln/>
+        </p:spPr>
+        <p:txBody>
+          <a:bodyPr wrap="square" lIns="0" tIns="0" rIns="0" bIns="0" rtlCol="0" anchor="ctr"/>
+          <a:lstStyle/>
+          <a:p>
+            <a:pPr indent="0" marL="0">
+              <a:lnSpc>
+                <a:spcPct val="112000"/>
+              </a:lnSpc>
+              <a:buNone/>
+            </a:pPr>
+            <a:r>
+              <a:rPr lang="en-US" sz="1200" dirty="0">
+                <a:solidFill>
+                  <a:srgbClr val="475569"/>
+                </a:solidFill>
+                <a:latin typeface="Calibri" pitchFamily="34" charset="0"/>
+                <a:ea typeface="Calibri" pitchFamily="34" charset="-122"/>
+                <a:cs typeface="Calibri" pitchFamily="34" charset="-120"/>
+              </a:rPr>
+              <a:t>Cyber Essentials / ISO evidence shortens procurement and security questionnaires — deals close sooner.</a:t>
+            </a:r>
+            <a:endParaRPr lang="en-US" sz="1200" dirty="0"/>
+          </a:p>
+        </p:txBody>
+      </p:sp>
+      <p:sp>
+        <p:nvSpPr>
+          <p:cNvPr id="24" name="Text 22"/>
+          <p:cNvSpPr/>
+          <p:nvPr/>
+        </p:nvSpPr>
+        <p:spPr>
+          <a:xfrm>
+            <a:off x="6556248" y="5394960"/>
+            <a:ext cx="4663440" cy="274320"/>
+          </a:xfrm>
+          <a:prstGeom prst="rect">
+            <a:avLst/>
+          </a:prstGeom>
+          <a:noFill/>
+          <a:ln/>
+        </p:spPr>
+        <p:txBody>
+          <a:bodyPr wrap="square" lIns="0" tIns="0" rIns="0" bIns="0" rtlCol="0" anchor="ctr"/>
+          <a:lstStyle/>
+          <a:p>
+            <a:pPr indent="0" marL="0">
+              <a:buNone/>
+            </a:pPr>
+            <a:r>
+              <a:rPr lang="en-US" sz="1100" dirty="0">
+                <a:solidFill>
+                  <a:srgbClr val="0D9488"/>
+                </a:solidFill>
+                <a:latin typeface="Consolas" pitchFamily="34" charset="0"/>
+                <a:ea typeface="Consolas" pitchFamily="34" charset="-122"/>
+                <a:cs typeface="Consolas" pitchFamily="34" charset="-120"/>
+              </a:rPr>
+              <a:t>faster time-to-revenue</a:t>
+            </a:r>
+            <a:endParaRPr lang="en-US" sz="1100" dirty="0"/>
+          </a:p>
+        </p:txBody>
+      </p:sp>
+      <p:sp>
+        <p:nvSpPr>
+          <p:cNvPr id="25" name="Text 23"/>
+          <p:cNvSpPr/>
+          <p:nvPr/>
+        </p:nvSpPr>
+        <p:spPr>
+          <a:xfrm>
+            <a:off x="822960" y="6053328"/>
+            <a:ext cx="10515600" cy="320040"/>
+          </a:xfrm>
+          <a:prstGeom prst="rect">
+            <a:avLst/>
+          </a:prstGeom>
+          <a:noFill/>
+          <a:ln/>
+        </p:spPr>
+        <p:txBody>
+          <a:bodyPr wrap="square" lIns="0" tIns="0" rIns="0" bIns="0" rtlCol="0" anchor="ctr"/>
+          <a:lstStyle/>
+          <a:p>
+            <a:pPr indent="0" marL="0">
+              <a:buNone/>
+            </a:pPr>
+            <a:r>
+              <a:rPr lang="en-US" sz="1150" i="1" dirty="0">
+                <a:solidFill>
+                  <a:srgbClr val="0D9488"/>
+                </a:solidFill>
+                <a:latin typeface="Calibri" pitchFamily="34" charset="0"/>
+                <a:ea typeface="Calibri" pitchFamily="34" charset="-122"/>
+                <a:cs typeface="Calibri" pitchFamily="34" charset="-120"/>
+              </a:rPr>
+              <a:t>Pays for itself on the first audit; breach-risk reduction and faster deals are upside. Figures illustrative — replace with your estate’s numbers.</a:t>
             </a:r>
             <a:endParaRPr lang="en-US" sz="1150" dirty="0"/>
           </a:p>
@@ -3477,7 +5198,7 @@
                 <a:ea typeface="Calibri" pitchFamily="34" charset="-122"/>
                 <a:cs typeface="Calibri" pitchFamily="34" charset="-120"/>
               </a:rPr>
-              <a:t>A Go tool that reads declarative Kubernetes manifests or a live cluster (read-only), finds the security misconfigurations that auditors and attackers both care about, links them into attack paths, and emits the fix — plus an auditor-ready compliance scorecard against six frameworks.</a:t>
+              <a:t>A Go tool that reads declarative Kubernetes manifests or a live cluster (read-only), finds the security misconfigurations that auditors and attackers both care about, links them into attack paths, and emits the fix — plus an auditor-ready compliance scorecard against nine frameworks.</a:t>
             </a:r>
             <a:endParaRPr lang="en-US" sz="1550" dirty="0"/>
           </a:p>
@@ -3537,7 +5258,7 @@
       </p:sp>
       <p:pic>
         <p:nvPicPr>
-          <p:cNvPr id="7" name="Image 0" descr="preencoded.png">    </p:cNvPr>
+          <p:cNvPr id="7" name="Image 0" descr="preencoded.png"/>
           <p:cNvPicPr>
             <a:picLocks noChangeAspect="1"/>
           </p:cNvPicPr>
@@ -3733,7 +5454,7 @@
       </p:sp>
       <p:pic>
         <p:nvPicPr>
-          <p:cNvPr id="13" name="Image 1" descr="preencoded.png">    </p:cNvPr>
+          <p:cNvPr id="13" name="Image 1" descr="preencoded.png"/>
           <p:cNvPicPr>
             <a:picLocks noChangeAspect="1"/>
           </p:cNvPicPr>
@@ -3929,7 +5650,7 @@
       </p:sp>
       <p:pic>
         <p:nvPicPr>
-          <p:cNvPr id="19" name="Image 2" descr="preencoded.png">    </p:cNvPr>
+          <p:cNvPr id="19" name="Image 2" descr="preencoded.png"/>
           <p:cNvPicPr>
             <a:picLocks noChangeAspect="1"/>
           </p:cNvPicPr>
@@ -4065,7 +5786,7 @@
                 <a:ea typeface="Calibri" pitchFamily="34" charset="-122"/>
                 <a:cs typeface="Calibri" pitchFamily="34" charset="-120"/>
               </a:rPr>
-              <a:t>Six deployment modes, one engine:  </a:t>
+              <a:t xml:space="preserve">Six deployment modes, one engine:  </a:t>
             </a:r>
             <a:pPr indent="0" marL="0">
               <a:buNone/>
@@ -4291,7 +6012,7 @@
       </p:sp>
       <p:pic>
         <p:nvPicPr>
-          <p:cNvPr id="7" name="Image 0" descr="preencoded.png">    </p:cNvPr>
+          <p:cNvPr id="7" name="Image 0" descr="preencoded.png"/>
           <p:cNvPicPr>
             <a:picLocks noChangeAspect="1"/>
           </p:cNvPicPr>
@@ -4448,7 +6169,7 @@
       </p:sp>
       <p:pic>
         <p:nvPicPr>
-          <p:cNvPr id="12" name="Image 1" descr="preencoded.png">    </p:cNvPr>
+          <p:cNvPr id="12" name="Image 1" descr="preencoded.png"/>
           <p:cNvPicPr>
             <a:picLocks noChangeAspect="1"/>
           </p:cNvPicPr>
@@ -4605,7 +6326,7 @@
       </p:sp>
       <p:pic>
         <p:nvPicPr>
-          <p:cNvPr id="17" name="Image 2" descr="preencoded.png">    </p:cNvPr>
+          <p:cNvPr id="17" name="Image 2" descr="preencoded.png"/>
           <p:cNvPicPr>
             <a:picLocks noChangeAspect="1"/>
           </p:cNvPicPr>
@@ -4762,7 +6483,7 @@
       </p:sp>
       <p:pic>
         <p:nvPicPr>
-          <p:cNvPr id="22" name="Image 3" descr="preencoded.png">    </p:cNvPr>
+          <p:cNvPr id="22" name="Image 3" descr="preencoded.png"/>
           <p:cNvPicPr>
             <a:picLocks noChangeAspect="1"/>
           </p:cNvPicPr>
@@ -5068,7 +6789,7 @@
       </p:sp>
       <p:pic>
         <p:nvPicPr>
-          <p:cNvPr id="6" name="Image 0" descr="preencoded.png">    </p:cNvPr>
+          <p:cNvPr id="6" name="Image 0" descr="preencoded.png"/>
           <p:cNvPicPr>
             <a:picLocks noChangeAspect="1"/>
           </p:cNvPicPr>
@@ -5264,7 +6985,7 @@
       </p:sp>
       <p:pic>
         <p:nvPicPr>
-          <p:cNvPr id="12" name="Image 1" descr="preencoded.png">    </p:cNvPr>
+          <p:cNvPr id="12" name="Image 1" descr="preencoded.png"/>
           <p:cNvPicPr>
             <a:picLocks noChangeAspect="1"/>
           </p:cNvPicPr>
@@ -5460,7 +7181,7 @@
       </p:sp>
       <p:pic>
         <p:nvPicPr>
-          <p:cNvPr id="18" name="Image 2" descr="preencoded.png">    </p:cNvPr>
+          <p:cNvPr id="18" name="Image 2" descr="preencoded.png"/>
           <p:cNvPicPr>
             <a:picLocks noChangeAspect="1"/>
           </p:cNvPicPr>
@@ -5656,7 +7377,7 @@
       </p:sp>
       <p:pic>
         <p:nvPicPr>
-          <p:cNvPr id="24" name="Image 3" descr="preencoded.png">    </p:cNvPr>
+          <p:cNvPr id="24" name="Image 3" descr="preencoded.png"/>
           <p:cNvPicPr>
             <a:picLocks noChangeAspect="1"/>
           </p:cNvPicPr>
@@ -5786,7 +7507,7 @@
       </p:sp>
       <p:pic>
         <p:nvPicPr>
-          <p:cNvPr id="28" name="Image 4" descr="preencoded.png">    </p:cNvPr>
+          <p:cNvPr id="28" name="Image 4" descr="preencoded.png"/>
           <p:cNvPicPr>
             <a:picLocks noChangeAspect="1"/>
           </p:cNvPicPr>
@@ -5943,7 +7664,7 @@
       </p:sp>
       <p:pic>
         <p:nvPicPr>
-          <p:cNvPr id="3" name="Image 0" descr="preencoded.png">    </p:cNvPr>
+          <p:cNvPr id="3" name="Image 0" descr="preencoded.png"/>
           <p:cNvPicPr>
             <a:picLocks noChangeAspect="1"/>
           </p:cNvPicPr>
@@ -6950,7 +8671,7 @@
                 <a:ea typeface="Calibri" pitchFamily="34" charset="-122"/>
                 <a:cs typeface="Calibri" pitchFamily="34" charset="-120"/>
               </a:rPr>
-              <a:t>Note:  </a:t>
+              <a:t xml:space="preserve">Note:  </a:t>
             </a:r>
             <a:pPr indent="0" marL="0">
               <a:buNone/>
@@ -7134,7 +8855,7 @@
       </p:sp>
       <p:pic>
         <p:nvPicPr>
-          <p:cNvPr id="6" name="Image 0" descr="preencoded.png">    </p:cNvPr>
+          <p:cNvPr id="6" name="Image 0" descr="preencoded.png"/>
           <p:cNvPicPr>
             <a:picLocks noChangeAspect="1"/>
           </p:cNvPicPr>
@@ -7291,7 +9012,7 @@
       </p:sp>
       <p:pic>
         <p:nvPicPr>
-          <p:cNvPr id="11" name="Image 1" descr="preencoded.png">    </p:cNvPr>
+          <p:cNvPr id="11" name="Image 1" descr="preencoded.png"/>
           <p:cNvPicPr>
             <a:picLocks noChangeAspect="1"/>
           </p:cNvPicPr>
@@ -7448,7 +9169,7 @@
       </p:sp>
       <p:pic>
         <p:nvPicPr>
-          <p:cNvPr id="16" name="Image 2" descr="preencoded.png">    </p:cNvPr>
+          <p:cNvPr id="16" name="Image 2" descr="preencoded.png"/>
           <p:cNvPicPr>
             <a:picLocks noChangeAspect="1"/>
           </p:cNvPicPr>
@@ -7605,7 +9326,7 @@
       </p:sp>
       <p:pic>
         <p:nvPicPr>
-          <p:cNvPr id="21" name="Image 3" descr="preencoded.png">    </p:cNvPr>
+          <p:cNvPr id="21" name="Image 3" descr="preencoded.png"/>
           <p:cNvPicPr>
             <a:picLocks noChangeAspect="1"/>
           </p:cNvPicPr>
@@ -7762,7 +9483,7 @@
       </p:sp>
       <p:pic>
         <p:nvPicPr>
-          <p:cNvPr id="3" name="Image 0" descr="preencoded.png">    </p:cNvPr>
+          <p:cNvPr id="3" name="Image 0" descr="preencoded.png"/>
           <p:cNvPicPr>
             <a:picLocks noChangeAspect="1"/>
           </p:cNvPicPr>
@@ -7898,7 +9619,7 @@
                 <a:ea typeface="Calibri" pitchFamily="34" charset="-122"/>
                 <a:cs typeface="Calibri" pitchFamily="34" charset="-120"/>
               </a:rPr>
-              <a:t>No UK pack ships out of the box, but KubeGuard’s control vocabulary lines up cleanly with the four regimes a UK organisation is measured against. The mapping below is indicative — a YAML pack makes it native.</a:t>
+              <a:t>KubeGuard now ships native UK packs — NCSC CAF 4.0, Cyber Essentials and UK GDPR / DPA 2018 — mapping the same cluster checks to each regime. The NIS mapping below is indicative; a YAML drop-in makes it native too.</a:t>
             </a:r>
             <a:endParaRPr lang="en-US" sz="1400" dirty="0"/>
           </a:p>
@@ -8756,7 +10477,7 @@
       </p:sp>
       <p:pic>
         <p:nvPicPr>
-          <p:cNvPr id="6" name="Image 0" descr="preencoded.png">    </p:cNvPr>
+          <p:cNvPr id="6" name="Image 0" descr="preencoded.png"/>
           <p:cNvPicPr>
             <a:picLocks noChangeAspect="1"/>
           </p:cNvPicPr>
@@ -8913,7 +10634,7 @@
       </p:sp>
       <p:pic>
         <p:nvPicPr>
-          <p:cNvPr id="11" name="Image 1" descr="preencoded.png">    </p:cNvPr>
+          <p:cNvPr id="11" name="Image 1" descr="preencoded.png"/>
           <p:cNvPicPr>
             <a:picLocks noChangeAspect="1"/>
           </p:cNvPicPr>
@@ -9070,7 +10791,7 @@
       </p:sp>
       <p:pic>
         <p:nvPicPr>
-          <p:cNvPr id="16" name="Image 2" descr="preencoded.png">    </p:cNvPr>
+          <p:cNvPr id="16" name="Image 2" descr="preencoded.png"/>
           <p:cNvPicPr>
             <a:picLocks noChangeAspect="1"/>
           </p:cNvPicPr>
@@ -9227,7 +10948,7 @@
       </p:sp>
       <p:pic>
         <p:nvPicPr>
-          <p:cNvPr id="21" name="Image 3" descr="preencoded.png">    </p:cNvPr>
+          <p:cNvPr id="21" name="Image 3" descr="preencoded.png"/>
           <p:cNvPicPr>
             <a:picLocks noChangeAspect="1"/>
           </p:cNvPicPr>
@@ -10203,7 +11924,7 @@
                 <a:ea typeface="Calibri" pitchFamily="34" charset="-122"/>
                 <a:cs typeface="Calibri" pitchFamily="34" charset="-120"/>
               </a:rPr>
-              <a:t>Six frameworks total — CIS Kubernetes Benchmark + the five above — each a data-driven YAML pack; adding a framework is a drop-in, not a code change.</a:t>
+              <a:t>Nine frameworks total — CIS, these four, plus the UK trio (CAF, Cyber Essentials, UK GDPR) and Saudi NCA ECC — each a data-driven YAML pack; adding a framework is a drop-in, not a code change.</a:t>
             </a:r>
             <a:endParaRPr lang="en-US" sz="1150" dirty="0"/>
           </a:p>

</xml_diff>